<commit_message>
Add funding rates, market orders, price chart; harden sessions/validation; refresh deck
Co-authored-by: arena-agent <297053741+arena-agent@users.noreply.github.com>
</commit_message>
<xml_diff>
--- a/hackathon-onchain-finance/demo-assets/avavault-perp-pitch-en.pptx
+++ b/hackathon-onchain-finance/demo-assets/avavault-perp-pitch-en.pptx
@@ -3528,7 +3528,7 @@
               </a:defRPr>
             </a:pPr>
             <a:r>
-              <a:t>•  GitHub: &lt;put your forked repo link here&gt;</a:t>
+              <a:t>•  GitHub: https://github.com/CodingGeoff/avavault-perp</a:t>
             </a:r>
           </a:p>
           <a:p>
@@ -4359,7 +4359,7 @@
               </a:defRPr>
             </a:pPr>
             <a:r>
-              <a:t>•  ORACLE · DEX Oracle — LFJ V1 live quotes via getAmountsOut on-chain pricing</a:t>
+              <a:t>•  ORACLE · DEX Oracle — LFJ V1 pool + TWAP time-weighted pricing, manipulation-resistant</a:t>
             </a:r>
           </a:p>
           <a:p>
@@ -4389,7 +4389,7 @@
               </a:defRPr>
             </a:pPr>
             <a:r>
-              <a:t>•  SETTLEMENT · Perp Vault — Off-chain matching + on-chain net settlement engine</a:t>
+              <a:t>•  SETTLEMENT · Perp Vault — Off-chain matching + signed on-chain settlement; positions/leverage/liquidation/insurance/funding</a:t>
             </a:r>
           </a:p>
         </p:txBody>
@@ -4598,7 +4598,7 @@
                 </a:solidFill>
                 <a:latin typeface="Arial"/>
               </a:rPr>
-              <a:t>MultiCollateralVault is really deployed on Fuji testnet</a:t>
+              <a:t>MultiCollateralVaultV2 is really deployed on Fuji testnet</a:t>
             </a:r>
           </a:p>
         </p:txBody>
@@ -4657,7 +4657,7 @@
                 </a:solidFill>
                 <a:latin typeface="Arial"/>
               </a:rPr>
-              <a:t>Verifiable on Snowtrace: contract creation + 3 real on-chain interactions</a:t>
+              <a:t>Verifiable on Snowtrace: contract creation + 3 real on-chain interactions (image: first V1 deployment; V2 address in repo README)</a:t>
             </a:r>
           </a:p>
         </p:txBody>
@@ -5520,7 +5520,7 @@
                 </a:solidFill>
                 <a:latin typeface="Arial"/>
               </a:rPr>
-              <a:t>Real signed login - real order book depth - real order fills</a:t>
+              <a:t>Real signed login - real order book depth - real order fills - live leveraged positions &amp; liquidation prices</a:t>
             </a:r>
           </a:p>
         </p:txBody>

</xml_diff>